<commit_message>
Document submitted hackathon entry and public demo
</commit_message>
<xml_diff>
--- a/docs/assets/Runway-Guard-Pitch.pptx
+++ b/docs/assets/Runway-Guard-Pitch.pptx
@@ -2,19 +2,19 @@
 <file path=ppt/presentation.xml><?xml version="1.0" encoding="utf-8"?>
 <p:presentation xmlns:p="http://schemas.openxmlformats.org/presentationml/2006/main">
   <p:sldMasterIdLst>
-    <p:sldMasterId xmlns:r="http://schemas.openxmlformats.org/officeDocument/2006/relationships" id="2147483648" r:id="R0fd37f1971fd40db"/>
+    <p:sldMasterId xmlns:r="http://schemas.openxmlformats.org/officeDocument/2006/relationships" id="2147483648" r:id="R7146b303db9d42cd"/>
   </p:sldMasterIdLst>
   <p:notesMasterIdLst>
-    <p:notesMasterId xmlns:r="http://schemas.openxmlformats.org/officeDocument/2006/relationships" r:id="R235f3c1cd68844f9"/>
+    <p:notesMasterId xmlns:r="http://schemas.openxmlformats.org/officeDocument/2006/relationships" r:id="Raac83d577e424c8f"/>
   </p:notesMasterIdLst>
   <p:sldIdLst>
-    <p:sldId xmlns:r="http://schemas.openxmlformats.org/officeDocument/2006/relationships" id="256" r:id="R61a72167e1e84264"/>
-    <p:sldId xmlns:r="http://schemas.openxmlformats.org/officeDocument/2006/relationships" id="257" r:id="Rfa82eb84587346dd"/>
-    <p:sldId xmlns:r="http://schemas.openxmlformats.org/officeDocument/2006/relationships" id="258" r:id="R5d9d984703a94609"/>
-    <p:sldId xmlns:r="http://schemas.openxmlformats.org/officeDocument/2006/relationships" id="259" r:id="R4c96d211346346e8"/>
-    <p:sldId xmlns:r="http://schemas.openxmlformats.org/officeDocument/2006/relationships" id="260" r:id="Re6ac4a3e666f4289"/>
-    <p:sldId xmlns:r="http://schemas.openxmlformats.org/officeDocument/2006/relationships" id="261" r:id="Rbf5147dd04af4aea"/>
-    <p:sldId xmlns:r="http://schemas.openxmlformats.org/officeDocument/2006/relationships" id="262" r:id="R9d8031fc51664e32"/>
+    <p:sldId xmlns:r="http://schemas.openxmlformats.org/officeDocument/2006/relationships" id="256" r:id="Reb990c281bf54537"/>
+    <p:sldId xmlns:r="http://schemas.openxmlformats.org/officeDocument/2006/relationships" id="257" r:id="Rb74c399c00744c95"/>
+    <p:sldId xmlns:r="http://schemas.openxmlformats.org/officeDocument/2006/relationships" id="258" r:id="Rff9f4c012b2044e5"/>
+    <p:sldId xmlns:r="http://schemas.openxmlformats.org/officeDocument/2006/relationships" id="259" r:id="R401d38f5fb534c89"/>
+    <p:sldId xmlns:r="http://schemas.openxmlformats.org/officeDocument/2006/relationships" id="260" r:id="Rbe8ec0a13ad1463a"/>
+    <p:sldId xmlns:r="http://schemas.openxmlformats.org/officeDocument/2006/relationships" id="261" r:id="R8602a5890fb04607"/>
+    <p:sldId xmlns:r="http://schemas.openxmlformats.org/officeDocument/2006/relationships" id="262" r:id="R2659ab255d214f0f"/>
   </p:sldIdLst>
   <p:sldSz cx="12192000" cy="6858000"/>
   <p:notesSz cx="6858000" cy="9144000"/>
@@ -868,7 +868,7 @@
           <a:lstStyle xmlns:a="http://schemas.openxmlformats.org/drawingml/2006/main"/>
           <a:p xmlns:a="http://schemas.openxmlformats.org/drawingml/2006/main">
             <a:r>
-              <a:t>Repository supplied by user: https://github.com/shi1720/coinmarketcap . Public deployment confirmed by product owner: https://runway-guard-cmc.web.app . Hosted video https://runway-guard-cmc.web.app/demo.html is ready. Authenticated own-key HTTP200 five-asset evidence is captured. The account is Basic and campaign Startup access remains unverified. DoraHacks contact fields are saved and Markets and Trading Tools is selected. Final agreement and the X post URL remain. No public BUIDL or X post URL exists. YouTube publication awaits explicit browser terms confirmation. Hackathon requirements: https://coinmarketcap.com/api/resources/api-hackathon/ . X post must link actual submission and demo video with#BuildwithCMC.</a:t>
+              <a:t>Repository supplied by user: https://github.com/shi1720/coinmarketcap . Public deployment confirmed by product owner: https://runway-guard-cmc.web.app . Hosted video https://runway-guard-cmc.web.app/demo.html is ready. Authenticated own-key HTTP200 five-asset evidence is captured. The account is Basic and campaign Startup access remains unverified. DoraHacks contact fields are saved and Markets and Trading Tools is selected. The user confirmed platform terms and publication. BUIDL https://dorahacks.io/buidl/49254 is submitted to Build with CMC under review. DoraHacks public visibility awaits moderation. Public YouTube https://youtu.be/CYLWG-bSSB8 playback verified. One X post https://x.com/ShivamGuptaim/status/2105269446298550656 links BUIDL and video with#BuildwithCMC. Latest mainCI b647 run36712404738 success. English35cueSRTuploaded butwatchCCpropagationunverified. No moderation approval or prize result claimed. Hackathon requirements: https://coinmarketcap.com/api/resources/api-hackathon/ . X post must link actual submission and demo video with#BuildwithCMC.</a:t>
             </a:r>
           </a:p>
         </p:txBody>
@@ -936,7 +936,7 @@
   </p:cSld>
   <p:clrMap bg1="lt1" tx1="dk1" bg2="lt2" tx2="dk2" accent1="accent1" accent2="accent2" accent3="accent3" accent4="accent4" accent5="accent5" accent6="accent6" hlink="hlink" folHlink="folHlink"/>
   <p:sldLayoutIdLst>
-    <p:sldLayoutId xmlns:r="http://schemas.openxmlformats.org/officeDocument/2006/relationships" id="2147483649" r:id="Re3e4392e584f46f6"/>
+    <p:sldLayoutId xmlns:r="http://schemas.openxmlformats.org/officeDocument/2006/relationships" id="2147483649" r:id="Rec6512793c274553"/>
   </p:sldLayoutIdLst>
   <p:txStyles>
     <p:titleStyle>
@@ -1487,7 +1487,7 @@
           <p:cNvPr id="6" name="">
             <a:extLst xmlns:a="http://schemas.openxmlformats.org/drawingml/2006/main">
               <a:ext uri="{FF2B5EF4-FFF2-40B4-BE49-F238E27FC236}">
-                <a16:creationId xmlns:a16="http://schemas.microsoft.com/office/drawing/2014/main" id="{9B40CC3E-3232-4606-97ED-C62EB405F224}"/>
+                <a16:creationId xmlns:a16="http://schemas.microsoft.com/office/drawing/2014/main" id="{0B3CC78A-B33B-47E6-86F7-1242FECCA758}"/>
               </a:ext>
             </a:extLst>
           </p:cNvPr>
@@ -1544,7 +1544,7 @@
           <p:cNvPr id="2" name="">
             <a:extLst xmlns:a="http://schemas.openxmlformats.org/drawingml/2006/main">
               <a:ext uri="{FF2B5EF4-FFF2-40B4-BE49-F238E27FC236}">
-                <a16:creationId xmlns:a16="http://schemas.microsoft.com/office/drawing/2014/main" id="{2166A66E-94D7-49A0-BADD-22ABE2509158}"/>
+                <a16:creationId xmlns:a16="http://schemas.microsoft.com/office/drawing/2014/main" id="{C395041C-84A4-4DF5-A30E-902884379921}"/>
               </a:ext>
             </a:extLst>
           </p:cNvPr>
@@ -1601,7 +1601,7 @@
           <p:cNvPr id="3" name="">
             <a:extLst xmlns:a="http://schemas.openxmlformats.org/drawingml/2006/main">
               <a:ext uri="{FF2B5EF4-FFF2-40B4-BE49-F238E27FC236}">
-                <a16:creationId xmlns:a16="http://schemas.microsoft.com/office/drawing/2014/main" id="{65AFBFDD-0371-4D08-8AC7-164F03F5F696}"/>
+                <a16:creationId xmlns:a16="http://schemas.microsoft.com/office/drawing/2014/main" id="{DCB9C872-2F8E-45EB-9E3F-B27BCAAAD7EB}"/>
               </a:ext>
             </a:extLst>
           </p:cNvPr>
@@ -1681,7 +1681,7 @@
           <p:cNvPr id="4" name="">
             <a:extLst xmlns:a="http://schemas.openxmlformats.org/drawingml/2006/main">
               <a:ext uri="{FF2B5EF4-FFF2-40B4-BE49-F238E27FC236}">
-                <a16:creationId xmlns:a16="http://schemas.microsoft.com/office/drawing/2014/main" id="{14D8122F-E72B-4481-9501-29EBC27FED29}"/>
+                <a16:creationId xmlns:a16="http://schemas.microsoft.com/office/drawing/2014/main" id="{A0216459-69F3-47F1-8FB3-21F36C3205E9}"/>
               </a:ext>
             </a:extLst>
           </p:cNvPr>
@@ -1738,7 +1738,7 @@
           <p:cNvPr id="5" name="">
             <a:extLst xmlns:a="http://schemas.openxmlformats.org/drawingml/2006/main">
               <a:ext uri="{FF2B5EF4-FFF2-40B4-BE49-F238E27FC236}">
-                <a16:creationId xmlns:a16="http://schemas.microsoft.com/office/drawing/2014/main" id="{CCAEB91B-C0F8-43F8-8944-3C11EA1242FE}"/>
+                <a16:creationId xmlns:a16="http://schemas.microsoft.com/office/drawing/2014/main" id="{CC88DA1A-3F66-4909-8089-8246D7535453}"/>
               </a:ext>
             </a:extLst>
           </p:cNvPr>
@@ -1793,7 +1793,7 @@
     </p:spTree>
     <p:extLst>
       <p:ext uri="{BB962C8B-B14F-4D97-AF65-F5344CB8AC3E}">
-        <p14:creationId xmlns:p14="http://schemas.microsoft.com/office/powerpoint/2010/main" val="677834694"/>
+        <p14:creationId xmlns:p14="http://schemas.microsoft.com/office/powerpoint/2010/main" val="564625213"/>
       </p:ext>
     </p:extLst>
   </p:cSld>
@@ -1824,7 +1824,7 @@
           <p:cNvPr id="11" name="">
             <a:extLst xmlns:a="http://schemas.openxmlformats.org/drawingml/2006/main">
               <a:ext uri="{FF2B5EF4-FFF2-40B4-BE49-F238E27FC236}">
-                <a16:creationId xmlns:a16="http://schemas.microsoft.com/office/drawing/2014/main" id="{85844F10-73C1-4EF6-ADA1-B07628338E0F}"/>
+                <a16:creationId xmlns:a16="http://schemas.microsoft.com/office/drawing/2014/main" id="{3C187E85-1938-4870-BEB0-54D4C11E3652}"/>
               </a:ext>
             </a:extLst>
           </p:cNvPr>
@@ -1881,7 +1881,7 @@
           <p:cNvPr id="2" name="">
             <a:extLst xmlns:a="http://schemas.openxmlformats.org/drawingml/2006/main">
               <a:ext uri="{FF2B5EF4-FFF2-40B4-BE49-F238E27FC236}">
-                <a16:creationId xmlns:a16="http://schemas.microsoft.com/office/drawing/2014/main" id="{3613C359-DE1D-47A6-B32C-643D72BCD9F4}"/>
+                <a16:creationId xmlns:a16="http://schemas.microsoft.com/office/drawing/2014/main" id="{4FABDEF6-F52B-4F6D-B2AF-22CAD851E0BA}"/>
               </a:ext>
             </a:extLst>
           </p:cNvPr>
@@ -1938,7 +1938,7 @@
           <p:cNvPr id="3" name="">
             <a:extLst xmlns:a="http://schemas.openxmlformats.org/drawingml/2006/main">
               <a:ext uri="{FF2B5EF4-FFF2-40B4-BE49-F238E27FC236}">
-                <a16:creationId xmlns:a16="http://schemas.microsoft.com/office/drawing/2014/main" id="{6B959C16-1301-4F5F-9D8A-949DF98C3E78}"/>
+                <a16:creationId xmlns:a16="http://schemas.microsoft.com/office/drawing/2014/main" id="{ABE7E9DF-F56A-4AD8-A158-D66788F70047}"/>
               </a:ext>
             </a:extLst>
           </p:cNvPr>
@@ -1995,7 +1995,7 @@
           <p:cNvPr id="4" name="">
             <a:extLst xmlns:a="http://schemas.openxmlformats.org/drawingml/2006/main">
               <a:ext uri="{FF2B5EF4-FFF2-40B4-BE49-F238E27FC236}">
-                <a16:creationId xmlns:a16="http://schemas.microsoft.com/office/drawing/2014/main" id="{90F0FE44-DE82-49FE-ABC4-CE08B2127861}"/>
+                <a16:creationId xmlns:a16="http://schemas.microsoft.com/office/drawing/2014/main" id="{98E7C129-4318-42C0-A1BB-7210DF224935}"/>
               </a:ext>
             </a:extLst>
           </p:cNvPr>
@@ -2052,7 +2052,7 @@
           <p:cNvPr id="5" name="">
             <a:extLst xmlns:a="http://schemas.openxmlformats.org/drawingml/2006/main">
               <a:ext uri="{FF2B5EF4-FFF2-40B4-BE49-F238E27FC236}">
-                <a16:creationId xmlns:a16="http://schemas.microsoft.com/office/drawing/2014/main" id="{6EB72064-0E14-4A31-A601-291CC913B269}"/>
+                <a16:creationId xmlns:a16="http://schemas.microsoft.com/office/drawing/2014/main" id="{6A88EC0F-9CA2-4EB5-A00B-EEF968736FD8}"/>
               </a:ext>
             </a:extLst>
           </p:cNvPr>
@@ -2109,7 +2109,7 @@
           <p:cNvPr id="6" name="">
             <a:extLst xmlns:a="http://schemas.openxmlformats.org/drawingml/2006/main">
               <a:ext uri="{FF2B5EF4-FFF2-40B4-BE49-F238E27FC236}">
-                <a16:creationId xmlns:a16="http://schemas.microsoft.com/office/drawing/2014/main" id="{63F8C9D5-91FF-40E4-91FC-C1017F7C727F}"/>
+                <a16:creationId xmlns:a16="http://schemas.microsoft.com/office/drawing/2014/main" id="{7D440050-753C-4775-A4C1-10D7C3D16BFB}"/>
               </a:ext>
             </a:extLst>
           </p:cNvPr>
@@ -2166,7 +2166,7 @@
           <p:cNvPr id="7" name="">
             <a:extLst xmlns:a="http://schemas.openxmlformats.org/drawingml/2006/main">
               <a:ext uri="{FF2B5EF4-FFF2-40B4-BE49-F238E27FC236}">
-                <a16:creationId xmlns:a16="http://schemas.microsoft.com/office/drawing/2014/main" id="{15C14BED-A7D2-4FF3-B7BD-8269BE025EFA}"/>
+                <a16:creationId xmlns:a16="http://schemas.microsoft.com/office/drawing/2014/main" id="{6D2A1277-4DAC-490B-867D-3789A644AC8B}"/>
               </a:ext>
             </a:extLst>
           </p:cNvPr>
@@ -2223,7 +2223,7 @@
           <p:cNvPr id="8" name="">
             <a:extLst xmlns:a="http://schemas.openxmlformats.org/drawingml/2006/main">
               <a:ext uri="{FF2B5EF4-FFF2-40B4-BE49-F238E27FC236}">
-                <a16:creationId xmlns:a16="http://schemas.microsoft.com/office/drawing/2014/main" id="{2099978A-9349-4477-A673-3D110855069A}"/>
+                <a16:creationId xmlns:a16="http://schemas.microsoft.com/office/drawing/2014/main" id="{D851A608-A0E2-45C4-B6D5-1CD043D54BE5}"/>
               </a:ext>
             </a:extLst>
           </p:cNvPr>
@@ -2280,7 +2280,7 @@
           <p:cNvPr id="9" name="">
             <a:extLst xmlns:a="http://schemas.openxmlformats.org/drawingml/2006/main">
               <a:ext uri="{FF2B5EF4-FFF2-40B4-BE49-F238E27FC236}">
-                <a16:creationId xmlns:a16="http://schemas.microsoft.com/office/drawing/2014/main" id="{48982639-4D16-4A96-B7CD-7F26D28BD2CC}"/>
+                <a16:creationId xmlns:a16="http://schemas.microsoft.com/office/drawing/2014/main" id="{9E19FB74-D813-4190-A533-59E8BB20BE08}"/>
               </a:ext>
             </a:extLst>
           </p:cNvPr>
@@ -2337,7 +2337,7 @@
           <p:cNvPr id="10" name="">
             <a:extLst xmlns:a="http://schemas.openxmlformats.org/drawingml/2006/main">
               <a:ext uri="{FF2B5EF4-FFF2-40B4-BE49-F238E27FC236}">
-                <a16:creationId xmlns:a16="http://schemas.microsoft.com/office/drawing/2014/main" id="{672DD886-EF01-4388-A233-71D65AA32D2E}"/>
+                <a16:creationId xmlns:a16="http://schemas.microsoft.com/office/drawing/2014/main" id="{41B33342-46D9-4EC9-9E8D-AB9AD78B65E1}"/>
               </a:ext>
             </a:extLst>
           </p:cNvPr>
@@ -2392,7 +2392,7 @@
     </p:spTree>
     <p:extLst>
       <p:ext uri="{BB962C8B-B14F-4D97-AF65-F5344CB8AC3E}">
-        <p14:creationId xmlns:p14="http://schemas.microsoft.com/office/powerpoint/2010/main" val="1548413245"/>
+        <p14:creationId xmlns:p14="http://schemas.microsoft.com/office/powerpoint/2010/main" val="116540180"/>
       </p:ext>
     </p:extLst>
   </p:cSld>
@@ -2423,7 +2423,7 @@
           <p:cNvPr id="15" name="">
             <a:extLst xmlns:a="http://schemas.openxmlformats.org/drawingml/2006/main">
               <a:ext uri="{FF2B5EF4-FFF2-40B4-BE49-F238E27FC236}">
-                <a16:creationId xmlns:a16="http://schemas.microsoft.com/office/drawing/2014/main" id="{8B244E02-B327-405D-96B4-F5486B77BD16}"/>
+                <a16:creationId xmlns:a16="http://schemas.microsoft.com/office/drawing/2014/main" id="{516867AC-4A8D-4FD7-86FF-BB60A240834E}"/>
               </a:ext>
             </a:extLst>
           </p:cNvPr>
@@ -2480,7 +2480,7 @@
           <p:cNvPr id="2" name="">
             <a:extLst xmlns:a="http://schemas.openxmlformats.org/drawingml/2006/main">
               <a:ext uri="{FF2B5EF4-FFF2-40B4-BE49-F238E27FC236}">
-                <a16:creationId xmlns:a16="http://schemas.microsoft.com/office/drawing/2014/main" id="{6C738D17-896F-4381-8B40-672F151F197A}"/>
+                <a16:creationId xmlns:a16="http://schemas.microsoft.com/office/drawing/2014/main" id="{3A6FCBAC-4061-4723-BC4E-8233F4634535}"/>
               </a:ext>
             </a:extLst>
           </p:cNvPr>
@@ -2537,7 +2537,7 @@
           <p:cNvPr id="3" name="">
             <a:extLst xmlns:a="http://schemas.openxmlformats.org/drawingml/2006/main">
               <a:ext uri="{FF2B5EF4-FFF2-40B4-BE49-F238E27FC236}">
-                <a16:creationId xmlns:a16="http://schemas.microsoft.com/office/drawing/2014/main" id="{900D5413-D4D4-461D-A54A-58DA7417FF4A}"/>
+                <a16:creationId xmlns:a16="http://schemas.microsoft.com/office/drawing/2014/main" id="{19D722E4-BC94-4C75-8668-95DB2433E30F}"/>
               </a:ext>
             </a:extLst>
           </p:cNvPr>
@@ -2594,7 +2594,7 @@
           <p:cNvPr id="4" name="">
             <a:extLst xmlns:a="http://schemas.openxmlformats.org/drawingml/2006/main">
               <a:ext uri="{FF2B5EF4-FFF2-40B4-BE49-F238E27FC236}">
-                <a16:creationId xmlns:a16="http://schemas.microsoft.com/office/drawing/2014/main" id="{27BCD0DF-ED7C-47B1-B110-4A9D8C4664B0}"/>
+                <a16:creationId xmlns:a16="http://schemas.microsoft.com/office/drawing/2014/main" id="{79A312DF-6DB5-4B55-9C38-3BC467BFC4B7}"/>
               </a:ext>
             </a:extLst>
           </p:cNvPr>
@@ -2651,7 +2651,7 @@
           <p:cNvPr id="5" name="">
             <a:extLst xmlns:a="http://schemas.openxmlformats.org/drawingml/2006/main">
               <a:ext uri="{FF2B5EF4-FFF2-40B4-BE49-F238E27FC236}">
-                <a16:creationId xmlns:a16="http://schemas.microsoft.com/office/drawing/2014/main" id="{B0EE3ADD-F5E9-4EE0-8714-D7343649E1CC}"/>
+                <a16:creationId xmlns:a16="http://schemas.microsoft.com/office/drawing/2014/main" id="{DC6D8E1B-A546-4132-B812-EEF336038A0C}"/>
               </a:ext>
             </a:extLst>
           </p:cNvPr>
@@ -2708,7 +2708,7 @@
           <p:cNvPr id="6" name="">
             <a:extLst xmlns:a="http://schemas.openxmlformats.org/drawingml/2006/main">
               <a:ext uri="{FF2B5EF4-FFF2-40B4-BE49-F238E27FC236}">
-                <a16:creationId xmlns:a16="http://schemas.microsoft.com/office/drawing/2014/main" id="{AF95F555-DFBC-473C-B182-C08424F79034}"/>
+                <a16:creationId xmlns:a16="http://schemas.microsoft.com/office/drawing/2014/main" id="{059D8C0C-B274-452B-828A-272B79452ADC}"/>
               </a:ext>
             </a:extLst>
           </p:cNvPr>
@@ -2765,7 +2765,7 @@
           <p:cNvPr id="7" name="">
             <a:extLst xmlns:a="http://schemas.openxmlformats.org/drawingml/2006/main">
               <a:ext uri="{FF2B5EF4-FFF2-40B4-BE49-F238E27FC236}">
-                <a16:creationId xmlns:a16="http://schemas.microsoft.com/office/drawing/2014/main" id="{35CDCF4E-0C69-4B7F-A4C7-9649835E7846}"/>
+                <a16:creationId xmlns:a16="http://schemas.microsoft.com/office/drawing/2014/main" id="{12D4A86B-7805-4610-959D-B604610BA021}"/>
               </a:ext>
             </a:extLst>
           </p:cNvPr>
@@ -2822,7 +2822,7 @@
           <p:cNvPr id="8" name="">
             <a:extLst xmlns:a="http://schemas.openxmlformats.org/drawingml/2006/main">
               <a:ext uri="{FF2B5EF4-FFF2-40B4-BE49-F238E27FC236}">
-                <a16:creationId xmlns:a16="http://schemas.microsoft.com/office/drawing/2014/main" id="{638DEDA0-EF3C-47CF-9283-907E207A07A1}"/>
+                <a16:creationId xmlns:a16="http://schemas.microsoft.com/office/drawing/2014/main" id="{B2F6701D-3310-48E7-9CC7-211BDE2B94FC}"/>
               </a:ext>
             </a:extLst>
           </p:cNvPr>
@@ -2879,7 +2879,7 @@
           <p:cNvPr id="9" name="">
             <a:extLst xmlns:a="http://schemas.openxmlformats.org/drawingml/2006/main">
               <a:ext uri="{FF2B5EF4-FFF2-40B4-BE49-F238E27FC236}">
-                <a16:creationId xmlns:a16="http://schemas.microsoft.com/office/drawing/2014/main" id="{F12332BC-1056-4E5A-BB15-46F8978EEED1}"/>
+                <a16:creationId xmlns:a16="http://schemas.microsoft.com/office/drawing/2014/main" id="{C64676D0-85C0-4B6F-A563-2C7665255B3E}"/>
               </a:ext>
             </a:extLst>
           </p:cNvPr>
@@ -2936,7 +2936,7 @@
           <p:cNvPr id="10" name="">
             <a:extLst xmlns:a="http://schemas.openxmlformats.org/drawingml/2006/main">
               <a:ext uri="{FF2B5EF4-FFF2-40B4-BE49-F238E27FC236}">
-                <a16:creationId xmlns:a16="http://schemas.microsoft.com/office/drawing/2014/main" id="{41D70631-6520-48D7-8372-D3A8AEA5E61E}"/>
+                <a16:creationId xmlns:a16="http://schemas.microsoft.com/office/drawing/2014/main" id="{4803DCFB-6E09-4C50-AC4E-D3061C46667A}"/>
               </a:ext>
             </a:extLst>
           </p:cNvPr>
@@ -2993,7 +2993,7 @@
           <p:cNvPr id="11" name="">
             <a:extLst xmlns:a="http://schemas.openxmlformats.org/drawingml/2006/main">
               <a:ext uri="{FF2B5EF4-FFF2-40B4-BE49-F238E27FC236}">
-                <a16:creationId xmlns:a16="http://schemas.microsoft.com/office/drawing/2014/main" id="{963DD3E9-4763-4FFB-9075-0C523C224F8D}"/>
+                <a16:creationId xmlns:a16="http://schemas.microsoft.com/office/drawing/2014/main" id="{51E61AE3-3F73-460E-B923-0522C6AA634F}"/>
               </a:ext>
             </a:extLst>
           </p:cNvPr>
@@ -3050,7 +3050,7 @@
           <p:cNvPr id="12" name="">
             <a:extLst xmlns:a="http://schemas.openxmlformats.org/drawingml/2006/main">
               <a:ext uri="{FF2B5EF4-FFF2-40B4-BE49-F238E27FC236}">
-                <a16:creationId xmlns:a16="http://schemas.microsoft.com/office/drawing/2014/main" id="{ED73AEC5-090C-4ACA-99A1-5D314AFCF0A1}"/>
+                <a16:creationId xmlns:a16="http://schemas.microsoft.com/office/drawing/2014/main" id="{8F2C96D3-B21E-4154-BF8C-44ABCBBCED61}"/>
               </a:ext>
             </a:extLst>
           </p:cNvPr>
@@ -3107,7 +3107,7 @@
           <p:cNvPr id="13" name="">
             <a:extLst xmlns:a="http://schemas.openxmlformats.org/drawingml/2006/main">
               <a:ext uri="{FF2B5EF4-FFF2-40B4-BE49-F238E27FC236}">
-                <a16:creationId xmlns:a16="http://schemas.microsoft.com/office/drawing/2014/main" id="{1CA56E5E-CF10-46F4-AA5C-9E7C6BD93753}"/>
+                <a16:creationId xmlns:a16="http://schemas.microsoft.com/office/drawing/2014/main" id="{52D35956-FCC1-403E-B294-9ACFE25DE49E}"/>
               </a:ext>
             </a:extLst>
           </p:cNvPr>
@@ -3164,7 +3164,7 @@
           <p:cNvPr id="14" name="">
             <a:extLst xmlns:a="http://schemas.openxmlformats.org/drawingml/2006/main">
               <a:ext uri="{FF2B5EF4-FFF2-40B4-BE49-F238E27FC236}">
-                <a16:creationId xmlns:a16="http://schemas.microsoft.com/office/drawing/2014/main" id="{7245D445-14EC-43AD-94E7-252DF3766858}"/>
+                <a16:creationId xmlns:a16="http://schemas.microsoft.com/office/drawing/2014/main" id="{A81B0838-7889-4D90-98EF-AA569F57AC58}"/>
               </a:ext>
             </a:extLst>
           </p:cNvPr>
@@ -3219,7 +3219,7 @@
     </p:spTree>
     <p:extLst>
       <p:ext uri="{BB962C8B-B14F-4D97-AF65-F5344CB8AC3E}">
-        <p14:creationId xmlns:p14="http://schemas.microsoft.com/office/powerpoint/2010/main" val="643324836"/>
+        <p14:creationId xmlns:p14="http://schemas.microsoft.com/office/powerpoint/2010/main" val="1277698518"/>
       </p:ext>
     </p:extLst>
   </p:cSld>
@@ -3250,7 +3250,7 @@
           <p:cNvPr id="11" name="">
             <a:extLst xmlns:a="http://schemas.openxmlformats.org/drawingml/2006/main">
               <a:ext uri="{FF2B5EF4-FFF2-40B4-BE49-F238E27FC236}">
-                <a16:creationId xmlns:a16="http://schemas.microsoft.com/office/drawing/2014/main" id="{BC1CE231-9FF7-47DD-8059-EF03139E1178}"/>
+                <a16:creationId xmlns:a16="http://schemas.microsoft.com/office/drawing/2014/main" id="{47A78B56-B4EB-483E-AA27-B75CFD5320AE}"/>
               </a:ext>
             </a:extLst>
           </p:cNvPr>
@@ -3307,7 +3307,7 @@
           <p:cNvPr id="2" name="">
             <a:extLst xmlns:a="http://schemas.openxmlformats.org/drawingml/2006/main">
               <a:ext uri="{FF2B5EF4-FFF2-40B4-BE49-F238E27FC236}">
-                <a16:creationId xmlns:a16="http://schemas.microsoft.com/office/drawing/2014/main" id="{DC6AD25D-7EE3-49D4-8A9C-C4D5FCFE2FA4}"/>
+                <a16:creationId xmlns:a16="http://schemas.microsoft.com/office/drawing/2014/main" id="{5EC5BC82-5834-4B39-ACC4-DA08D47C2793}"/>
               </a:ext>
             </a:extLst>
           </p:cNvPr>
@@ -3364,7 +3364,7 @@
           <p:cNvPr id="3" name="">
             <a:extLst xmlns:a="http://schemas.openxmlformats.org/drawingml/2006/main">
               <a:ext uri="{FF2B5EF4-FFF2-40B4-BE49-F238E27FC236}">
-                <a16:creationId xmlns:a16="http://schemas.microsoft.com/office/drawing/2014/main" id="{6235A87C-E8EE-432B-89C1-BDC0E40B4FC1}"/>
+                <a16:creationId xmlns:a16="http://schemas.microsoft.com/office/drawing/2014/main" id="{02ED5EA9-6D36-4AB3-B448-8CF027F32B67}"/>
               </a:ext>
             </a:extLst>
           </p:cNvPr>
@@ -3421,7 +3421,7 @@
           <p:cNvPr id="4" name="">
             <a:extLst xmlns:a="http://schemas.openxmlformats.org/drawingml/2006/main">
               <a:ext uri="{FF2B5EF4-FFF2-40B4-BE49-F238E27FC236}">
-                <a16:creationId xmlns:a16="http://schemas.microsoft.com/office/drawing/2014/main" id="{7A08814B-73D7-4647-918C-DCB829F0A74B}"/>
+                <a16:creationId xmlns:a16="http://schemas.microsoft.com/office/drawing/2014/main" id="{2F1E4257-211F-4A1A-8DB7-0E2EC288ACE2}"/>
               </a:ext>
             </a:extLst>
           </p:cNvPr>
@@ -3478,7 +3478,7 @@
           <p:cNvPr id="5" name="">
             <a:extLst xmlns:a="http://schemas.openxmlformats.org/drawingml/2006/main">
               <a:ext uri="{FF2B5EF4-FFF2-40B4-BE49-F238E27FC236}">
-                <a16:creationId xmlns:a16="http://schemas.microsoft.com/office/drawing/2014/main" id="{517F9D0B-C8F6-4D1F-8071-4FE94A2AE040}"/>
+                <a16:creationId xmlns:a16="http://schemas.microsoft.com/office/drawing/2014/main" id="{EB5C11FA-8A16-425D-AD08-385D1012DF3A}"/>
               </a:ext>
             </a:extLst>
           </p:cNvPr>
@@ -3535,7 +3535,7 @@
           <p:cNvPr id="6" name="">
             <a:extLst xmlns:a="http://schemas.openxmlformats.org/drawingml/2006/main">
               <a:ext uri="{FF2B5EF4-FFF2-40B4-BE49-F238E27FC236}">
-                <a16:creationId xmlns:a16="http://schemas.microsoft.com/office/drawing/2014/main" id="{4661A651-9893-424C-B6E9-30790BF3E170}"/>
+                <a16:creationId xmlns:a16="http://schemas.microsoft.com/office/drawing/2014/main" id="{3A47D541-FC9D-4A76-8171-9087E0521201}"/>
               </a:ext>
             </a:extLst>
           </p:cNvPr>
@@ -3592,7 +3592,7 @@
           <p:cNvPr id="7" name="">
             <a:extLst xmlns:a="http://schemas.openxmlformats.org/drawingml/2006/main">
               <a:ext uri="{FF2B5EF4-FFF2-40B4-BE49-F238E27FC236}">
-                <a16:creationId xmlns:a16="http://schemas.microsoft.com/office/drawing/2014/main" id="{801F4276-9004-4F2C-94F5-2D3C09A14B31}"/>
+                <a16:creationId xmlns:a16="http://schemas.microsoft.com/office/drawing/2014/main" id="{8489C584-3C31-4199-A3AF-F1F35D81915C}"/>
               </a:ext>
             </a:extLst>
           </p:cNvPr>
@@ -3649,7 +3649,7 @@
           <p:cNvPr id="8" name="">
             <a:extLst xmlns:a="http://schemas.openxmlformats.org/drawingml/2006/main">
               <a:ext uri="{FF2B5EF4-FFF2-40B4-BE49-F238E27FC236}">
-                <a16:creationId xmlns:a16="http://schemas.microsoft.com/office/drawing/2014/main" id="{670F9C90-B069-4D1F-91CB-49FF4AA87A32}"/>
+                <a16:creationId xmlns:a16="http://schemas.microsoft.com/office/drawing/2014/main" id="{4A609E67-C8E8-4384-AF26-1F6FE0E879F6}"/>
               </a:ext>
             </a:extLst>
           </p:cNvPr>
@@ -3706,7 +3706,7 @@
           <p:cNvPr id="9" name="">
             <a:extLst xmlns:a="http://schemas.openxmlformats.org/drawingml/2006/main">
               <a:ext uri="{FF2B5EF4-FFF2-40B4-BE49-F238E27FC236}">
-                <a16:creationId xmlns:a16="http://schemas.microsoft.com/office/drawing/2014/main" id="{D2F7D3AE-6C35-4EAB-AB99-C3C21DFFDE96}"/>
+                <a16:creationId xmlns:a16="http://schemas.microsoft.com/office/drawing/2014/main" id="{431DA0A2-653D-43E6-895A-181FA2C55716}"/>
               </a:ext>
             </a:extLst>
           </p:cNvPr>
@@ -3763,7 +3763,7 @@
           <p:cNvPr id="10" name="">
             <a:extLst xmlns:a="http://schemas.openxmlformats.org/drawingml/2006/main">
               <a:ext uri="{FF2B5EF4-FFF2-40B4-BE49-F238E27FC236}">
-                <a16:creationId xmlns:a16="http://schemas.microsoft.com/office/drawing/2014/main" id="{5DF6734D-9B0F-4F6C-84C2-72EC66419DFA}"/>
+                <a16:creationId xmlns:a16="http://schemas.microsoft.com/office/drawing/2014/main" id="{5DFD5261-93CB-4479-A61D-F264AA6A4AA5}"/>
               </a:ext>
             </a:extLst>
           </p:cNvPr>
@@ -3841,7 +3841,7 @@
     </p:spTree>
     <p:extLst>
       <p:ext uri="{BB962C8B-B14F-4D97-AF65-F5344CB8AC3E}">
-        <p14:creationId xmlns:p14="http://schemas.microsoft.com/office/powerpoint/2010/main" val="530123722"/>
+        <p14:creationId xmlns:p14="http://schemas.microsoft.com/office/powerpoint/2010/main" val="1760115011"/>
       </p:ext>
     </p:extLst>
   </p:cSld>
@@ -3872,7 +3872,7 @@
           <p:cNvPr id="9" name="">
             <a:extLst xmlns:a="http://schemas.openxmlformats.org/drawingml/2006/main">
               <a:ext uri="{FF2B5EF4-FFF2-40B4-BE49-F238E27FC236}">
-                <a16:creationId xmlns:a16="http://schemas.microsoft.com/office/drawing/2014/main" id="{6A03E88D-9A9D-47A3-AE38-4F9FD111E075}"/>
+                <a16:creationId xmlns:a16="http://schemas.microsoft.com/office/drawing/2014/main" id="{4978D1E4-DB2D-4F21-B855-23581273AF29}"/>
               </a:ext>
             </a:extLst>
           </p:cNvPr>
@@ -3929,7 +3929,7 @@
           <p:cNvPr id="2" name="">
             <a:extLst xmlns:a="http://schemas.openxmlformats.org/drawingml/2006/main">
               <a:ext uri="{FF2B5EF4-FFF2-40B4-BE49-F238E27FC236}">
-                <a16:creationId xmlns:a16="http://schemas.microsoft.com/office/drawing/2014/main" id="{875B1619-D99B-49B2-B083-2B1BC16A3536}"/>
+                <a16:creationId xmlns:a16="http://schemas.microsoft.com/office/drawing/2014/main" id="{C5D032ED-FA13-45A1-A02D-4F9BA8936B39}"/>
               </a:ext>
             </a:extLst>
           </p:cNvPr>
@@ -3986,7 +3986,7 @@
           <p:cNvPr id="3" name="">
             <a:extLst xmlns:a="http://schemas.openxmlformats.org/drawingml/2006/main">
               <a:ext uri="{FF2B5EF4-FFF2-40B4-BE49-F238E27FC236}">
-                <a16:creationId xmlns:a16="http://schemas.microsoft.com/office/drawing/2014/main" id="{E28CDE18-FA78-4136-B8C4-3D231BC2DC9D}"/>
+                <a16:creationId xmlns:a16="http://schemas.microsoft.com/office/drawing/2014/main" id="{630A0FE3-05DA-4BB8-9F72-96CF77AECA5E}"/>
               </a:ext>
             </a:extLst>
           </p:cNvPr>
@@ -4043,7 +4043,7 @@
           <p:cNvPr id="4" name="">
             <a:extLst xmlns:a="http://schemas.openxmlformats.org/drawingml/2006/main">
               <a:ext uri="{FF2B5EF4-FFF2-40B4-BE49-F238E27FC236}">
-                <a16:creationId xmlns:a16="http://schemas.microsoft.com/office/drawing/2014/main" id="{762C5342-B54E-4DFF-9F5A-D1EE4F654269}"/>
+                <a16:creationId xmlns:a16="http://schemas.microsoft.com/office/drawing/2014/main" id="{F982A99F-E5DD-4584-80D8-23E44CE78135}"/>
               </a:ext>
             </a:extLst>
           </p:cNvPr>
@@ -4169,7 +4169,7 @@
           <p:cNvPr id="5" name="">
             <a:extLst xmlns:a="http://schemas.openxmlformats.org/drawingml/2006/main">
               <a:ext uri="{FF2B5EF4-FFF2-40B4-BE49-F238E27FC236}">
-                <a16:creationId xmlns:a16="http://schemas.microsoft.com/office/drawing/2014/main" id="{8B92A711-56C3-4ABF-B334-A7D9868A6D25}"/>
+                <a16:creationId xmlns:a16="http://schemas.microsoft.com/office/drawing/2014/main" id="{4A965C7D-610E-46A7-8F57-88E089E08084}"/>
               </a:ext>
             </a:extLst>
           </p:cNvPr>
@@ -4226,7 +4226,7 @@
           <p:cNvPr id="6" name="">
             <a:extLst xmlns:a="http://schemas.openxmlformats.org/drawingml/2006/main">
               <a:ext uri="{FF2B5EF4-FFF2-40B4-BE49-F238E27FC236}">
-                <a16:creationId xmlns:a16="http://schemas.microsoft.com/office/drawing/2014/main" id="{DAA65A14-D6C3-41AF-B426-B5B53BD0732D}"/>
+                <a16:creationId xmlns:a16="http://schemas.microsoft.com/office/drawing/2014/main" id="{7B795807-2B89-4523-A5FC-A233E45B636D}"/>
               </a:ext>
             </a:extLst>
           </p:cNvPr>
@@ -4352,7 +4352,7 @@
           <p:cNvPr id="7" name="">
             <a:extLst xmlns:a="http://schemas.openxmlformats.org/drawingml/2006/main">
               <a:ext uri="{FF2B5EF4-FFF2-40B4-BE49-F238E27FC236}">
-                <a16:creationId xmlns:a16="http://schemas.microsoft.com/office/drawing/2014/main" id="{5D859B4B-F7AB-4C3C-B2AF-DE5FD849C96E}"/>
+                <a16:creationId xmlns:a16="http://schemas.microsoft.com/office/drawing/2014/main" id="{5BDFEDAA-B7A2-467C-8028-3A9F3973F2A6}"/>
               </a:ext>
             </a:extLst>
           </p:cNvPr>
@@ -4409,7 +4409,7 @@
           <p:cNvPr id="8" name="">
             <a:extLst xmlns:a="http://schemas.openxmlformats.org/drawingml/2006/main">
               <a:ext uri="{FF2B5EF4-FFF2-40B4-BE49-F238E27FC236}">
-                <a16:creationId xmlns:a16="http://schemas.microsoft.com/office/drawing/2014/main" id="{D69BA80A-B25F-4AC8-84C9-ABE6B394F456}"/>
+                <a16:creationId xmlns:a16="http://schemas.microsoft.com/office/drawing/2014/main" id="{114A9B0E-5060-425C-AAFE-84266D9E6158}"/>
               </a:ext>
             </a:extLst>
           </p:cNvPr>
@@ -4464,7 +4464,7 @@
     </p:spTree>
     <p:extLst>
       <p:ext uri="{BB962C8B-B14F-4D97-AF65-F5344CB8AC3E}">
-        <p14:creationId xmlns:p14="http://schemas.microsoft.com/office/powerpoint/2010/main" val="1352371410"/>
+        <p14:creationId xmlns:p14="http://schemas.microsoft.com/office/powerpoint/2010/main" val="391137126"/>
       </p:ext>
     </p:extLst>
   </p:cSld>
@@ -4495,7 +4495,7 @@
           <p:cNvPr id="13" name="">
             <a:extLst xmlns:a="http://schemas.openxmlformats.org/drawingml/2006/main">
               <a:ext uri="{FF2B5EF4-FFF2-40B4-BE49-F238E27FC236}">
-                <a16:creationId xmlns:a16="http://schemas.microsoft.com/office/drawing/2014/main" id="{B9F4FDEC-8E58-46C1-9AA7-2BD60A5786F9}"/>
+                <a16:creationId xmlns:a16="http://schemas.microsoft.com/office/drawing/2014/main" id="{2DC2D22B-0DD7-4C56-94C6-56AAA0C0C60B}"/>
               </a:ext>
             </a:extLst>
           </p:cNvPr>
@@ -4552,7 +4552,7 @@
           <p:cNvPr id="2" name="">
             <a:extLst xmlns:a="http://schemas.openxmlformats.org/drawingml/2006/main">
               <a:ext uri="{FF2B5EF4-FFF2-40B4-BE49-F238E27FC236}">
-                <a16:creationId xmlns:a16="http://schemas.microsoft.com/office/drawing/2014/main" id="{04DD2CF6-2B5C-4C1C-8490-DC9C6F697E56}"/>
+                <a16:creationId xmlns:a16="http://schemas.microsoft.com/office/drawing/2014/main" id="{D223C336-11B0-402E-8E01-30E4E7D471E7}"/>
               </a:ext>
             </a:extLst>
           </p:cNvPr>
@@ -4609,7 +4609,7 @@
           <p:cNvPr id="3" name="">
             <a:extLst xmlns:a="http://schemas.openxmlformats.org/drawingml/2006/main">
               <a:ext uri="{FF2B5EF4-FFF2-40B4-BE49-F238E27FC236}">
-                <a16:creationId xmlns:a16="http://schemas.microsoft.com/office/drawing/2014/main" id="{F1AF0003-5E12-4D07-8276-2FD06D9423DC}"/>
+                <a16:creationId xmlns:a16="http://schemas.microsoft.com/office/drawing/2014/main" id="{CBBB784C-6D6A-4842-82CE-883F5777D570}"/>
               </a:ext>
             </a:extLst>
           </p:cNvPr>
@@ -4666,7 +4666,7 @@
           <p:cNvPr id="4" name="">
             <a:extLst xmlns:a="http://schemas.openxmlformats.org/drawingml/2006/main">
               <a:ext uri="{FF2B5EF4-FFF2-40B4-BE49-F238E27FC236}">
-                <a16:creationId xmlns:a16="http://schemas.microsoft.com/office/drawing/2014/main" id="{A70759F5-E3CB-47F6-BE00-B5E1FA608CE1}"/>
+                <a16:creationId xmlns:a16="http://schemas.microsoft.com/office/drawing/2014/main" id="{0BDEDB91-750D-4C00-BEBF-B2CBB9C66CD8}"/>
               </a:ext>
             </a:extLst>
           </p:cNvPr>
@@ -4723,7 +4723,7 @@
           <p:cNvPr id="5" name="">
             <a:extLst xmlns:a="http://schemas.openxmlformats.org/drawingml/2006/main">
               <a:ext uri="{FF2B5EF4-FFF2-40B4-BE49-F238E27FC236}">
-                <a16:creationId xmlns:a16="http://schemas.microsoft.com/office/drawing/2014/main" id="{A91C1F3F-FABF-49BC-B830-32108941946B}"/>
+                <a16:creationId xmlns:a16="http://schemas.microsoft.com/office/drawing/2014/main" id="{172B705C-B5AA-4BF6-88D9-CFD42125A4BF}"/>
               </a:ext>
             </a:extLst>
           </p:cNvPr>
@@ -4780,7 +4780,7 @@
           <p:cNvPr id="6" name="">
             <a:extLst xmlns:a="http://schemas.openxmlformats.org/drawingml/2006/main">
               <a:ext uri="{FF2B5EF4-FFF2-40B4-BE49-F238E27FC236}">
-                <a16:creationId xmlns:a16="http://schemas.microsoft.com/office/drawing/2014/main" id="{C4FD6E31-12BE-4F31-BD1E-0E88C27D11FC}"/>
+                <a16:creationId xmlns:a16="http://schemas.microsoft.com/office/drawing/2014/main" id="{E6493215-F054-4920-8822-A2591A65A935}"/>
               </a:ext>
             </a:extLst>
           </p:cNvPr>
@@ -4837,7 +4837,7 @@
           <p:cNvPr id="7" name="">
             <a:extLst xmlns:a="http://schemas.openxmlformats.org/drawingml/2006/main">
               <a:ext uri="{FF2B5EF4-FFF2-40B4-BE49-F238E27FC236}">
-                <a16:creationId xmlns:a16="http://schemas.microsoft.com/office/drawing/2014/main" id="{8E755472-1589-4864-93E7-B6B0C646640C}"/>
+                <a16:creationId xmlns:a16="http://schemas.microsoft.com/office/drawing/2014/main" id="{895E70A7-E2FE-4B76-B755-F85D49B4B3A6}"/>
               </a:ext>
             </a:extLst>
           </p:cNvPr>
@@ -4917,7 +4917,7 @@
           <p:cNvPr id="8" name="">
             <a:extLst xmlns:a="http://schemas.openxmlformats.org/drawingml/2006/main">
               <a:ext uri="{FF2B5EF4-FFF2-40B4-BE49-F238E27FC236}">
-                <a16:creationId xmlns:a16="http://schemas.microsoft.com/office/drawing/2014/main" id="{83C18A79-ED48-4A1C-B600-C51331BD38F4}"/>
+                <a16:creationId xmlns:a16="http://schemas.microsoft.com/office/drawing/2014/main" id="{1C131EA3-3BCD-4555-BA1F-85CFA16A9D4C}"/>
               </a:ext>
             </a:extLst>
           </p:cNvPr>
@@ -4974,7 +4974,7 @@
           <p:cNvPr id="9" name="">
             <a:extLst xmlns:a="http://schemas.openxmlformats.org/drawingml/2006/main">
               <a:ext uri="{FF2B5EF4-FFF2-40B4-BE49-F238E27FC236}">
-                <a16:creationId xmlns:a16="http://schemas.microsoft.com/office/drawing/2014/main" id="{26865BCF-5955-48A8-8434-6434AFB40C83}"/>
+                <a16:creationId xmlns:a16="http://schemas.microsoft.com/office/drawing/2014/main" id="{85EBE676-5399-455E-918A-72FD456B25D4}"/>
               </a:ext>
             </a:extLst>
           </p:cNvPr>
@@ -5054,7 +5054,7 @@
           <p:cNvPr id="10" name="">
             <a:extLst xmlns:a="http://schemas.openxmlformats.org/drawingml/2006/main">
               <a:ext uri="{FF2B5EF4-FFF2-40B4-BE49-F238E27FC236}">
-                <a16:creationId xmlns:a16="http://schemas.microsoft.com/office/drawing/2014/main" id="{F95A0B84-DAC6-43C5-BF40-0ADEBA187F7E}"/>
+                <a16:creationId xmlns:a16="http://schemas.microsoft.com/office/drawing/2014/main" id="{9789D560-BE50-498E-A3BF-1DDE0D56B820}"/>
               </a:ext>
             </a:extLst>
           </p:cNvPr>
@@ -5111,7 +5111,7 @@
           <p:cNvPr id="11" name="">
             <a:extLst xmlns:a="http://schemas.openxmlformats.org/drawingml/2006/main">
               <a:ext uri="{FF2B5EF4-FFF2-40B4-BE49-F238E27FC236}">
-                <a16:creationId xmlns:a16="http://schemas.microsoft.com/office/drawing/2014/main" id="{3821B117-F3C0-4363-8A2A-64B42C78ECF6}"/>
+                <a16:creationId xmlns:a16="http://schemas.microsoft.com/office/drawing/2014/main" id="{01500EFC-529A-4CBC-9EF3-E7422F6B0151}"/>
               </a:ext>
             </a:extLst>
           </p:cNvPr>
@@ -5168,7 +5168,7 @@
           <p:cNvPr id="12" name="">
             <a:extLst xmlns:a="http://schemas.openxmlformats.org/drawingml/2006/main">
               <a:ext uri="{FF2B5EF4-FFF2-40B4-BE49-F238E27FC236}">
-                <a16:creationId xmlns:a16="http://schemas.microsoft.com/office/drawing/2014/main" id="{7DD34286-2B74-43F5-82F7-B6828CD5332E}"/>
+                <a16:creationId xmlns:a16="http://schemas.microsoft.com/office/drawing/2014/main" id="{0548C8F9-5783-4929-A17A-48735CE98B6A}"/>
               </a:ext>
             </a:extLst>
           </p:cNvPr>
@@ -5223,7 +5223,7 @@
     </p:spTree>
     <p:extLst>
       <p:ext uri="{BB962C8B-B14F-4D97-AF65-F5344CB8AC3E}">
-        <p14:creationId xmlns:p14="http://schemas.microsoft.com/office/powerpoint/2010/main" val="1526912551"/>
+        <p14:creationId xmlns:p14="http://schemas.microsoft.com/office/powerpoint/2010/main" val="157549805"/>
       </p:ext>
     </p:extLst>
   </p:cSld>
@@ -5251,10 +5251,10 @@
       </p:grpSpPr>
       <p:sp>
         <p:nvSpPr>
-          <p:cNvPr id="9" name="">
-            <a:extLst xmlns:a="http://schemas.openxmlformats.org/drawingml/2006/main">
-              <a:ext uri="{FF2B5EF4-FFF2-40B4-BE49-F238E27FC236}">
-                <a16:creationId xmlns:a16="http://schemas.microsoft.com/office/drawing/2014/main" id="{44B80892-F2C6-493A-A01F-111505D03F61}"/>
+          <p:cNvPr id="11" name="">
+            <a:extLst xmlns:a="http://schemas.openxmlformats.org/drawingml/2006/main">
+              <a:ext uri="{FF2B5EF4-FFF2-40B4-BE49-F238E27FC236}">
+                <a16:creationId xmlns:a16="http://schemas.microsoft.com/office/drawing/2014/main" id="{1B8AD2D6-7B11-458E-B3F2-CB8F07C0D7A0}"/>
               </a:ext>
             </a:extLst>
           </p:cNvPr>
@@ -5311,7 +5311,7 @@
           <p:cNvPr id="2" name="">
             <a:extLst xmlns:a="http://schemas.openxmlformats.org/drawingml/2006/main">
               <a:ext uri="{FF2B5EF4-FFF2-40B4-BE49-F238E27FC236}">
-                <a16:creationId xmlns:a16="http://schemas.microsoft.com/office/drawing/2014/main" id="{B0E33E64-9698-4BCF-A722-BC06A39FA750}"/>
+                <a16:creationId xmlns:a16="http://schemas.microsoft.com/office/drawing/2014/main" id="{FA2205BA-82C3-4DF2-AB17-41CBB3582385}"/>
               </a:ext>
             </a:extLst>
           </p:cNvPr>
@@ -5368,7 +5368,7 @@
           <p:cNvPr id="3" name="">
             <a:extLst xmlns:a="http://schemas.openxmlformats.org/drawingml/2006/main">
               <a:ext uri="{FF2B5EF4-FFF2-40B4-BE49-F238E27FC236}">
-                <a16:creationId xmlns:a16="http://schemas.microsoft.com/office/drawing/2014/main" id="{563522DC-AC21-4CF9-BBAD-F29D0746F043}"/>
+                <a16:creationId xmlns:a16="http://schemas.microsoft.com/office/drawing/2014/main" id="{673620F9-ACBC-4E96-9EA8-45AD732245EF}"/>
               </a:ext>
             </a:extLst>
           </p:cNvPr>
@@ -5425,7 +5425,7 @@
           <p:cNvPr id="4" name="">
             <a:extLst xmlns:a="http://schemas.openxmlformats.org/drawingml/2006/main">
               <a:ext uri="{FF2B5EF4-FFF2-40B4-BE49-F238E27FC236}">
-                <a16:creationId xmlns:a16="http://schemas.microsoft.com/office/drawing/2014/main" id="{A089EB87-CAA6-46D6-A6A0-F624E43148F5}"/>
+                <a16:creationId xmlns:a16="http://schemas.microsoft.com/office/drawing/2014/main" id="{F0202C05-E61F-45D7-A0FA-101D6358461C}"/>
               </a:ext>
             </a:extLst>
           </p:cNvPr>
@@ -5482,7 +5482,64 @@
           <p:cNvPr id="5" name="">
             <a:extLst xmlns:a="http://schemas.openxmlformats.org/drawingml/2006/main">
               <a:ext uri="{FF2B5EF4-FFF2-40B4-BE49-F238E27FC236}">
-                <a16:creationId xmlns:a16="http://schemas.microsoft.com/office/drawing/2014/main" id="{7E12E4AD-70F1-475C-BB97-2AF8111FD9C4}"/>
+                <a16:creationId xmlns:a16="http://schemas.microsoft.com/office/drawing/2014/main" id="{41E27A0E-6788-433C-80CB-D8091F130E46}"/>
+              </a:ext>
+            </a:extLst>
+          </p:cNvPr>
+          <p:cNvSpPr>
+            <a:spLocks xmlns:a="http://schemas.openxmlformats.org/drawingml/2006/main" noGrp="1"/>
+          </p:cNvSpPr>
+          <p:nvPr/>
+        </p:nvSpPr>
+        <p:spPr>
+          <a:xfrm xmlns:a="http://schemas.openxmlformats.org/drawingml/2006/main">
+            <a:off x="685800" y="3476625"/>
+            <a:ext cx="10820400" cy="323850"/>
+          </a:xfrm>
+          <a:prstGeom xmlns:a="http://schemas.openxmlformats.org/drawingml/2006/main" prst="rect">
+            <a:avLst/>
+          </a:prstGeom>
+          <a:noFill xmlns:a="http://schemas.openxmlformats.org/drawingml/2006/main"/>
+          <a:ln xmlns:a="http://schemas.openxmlformats.org/drawingml/2006/main" w="0">
+            <a:noFill/>
+          </a:ln>
+        </p:spPr>
+        <p:txBody>
+          <a:bodyPr xmlns:a="http://schemas.openxmlformats.org/drawingml/2006/main">
+            <a:noAutofit/>
+          </a:bodyPr>
+          <a:lstStyle xmlns:a="http://schemas.openxmlformats.org/drawingml/2006/main"/>
+          <a:p xmlns:a="http://schemas.openxmlformats.org/drawingml/2006/main">
+            <a:pPr>
+              <a:defRPr sz="1725" b="0">
+                <a:solidFill>
+                  <a:srgbClr val="B5EF6B"/>
+                </a:solidFill>
+                <a:latin typeface="Helvetica Neue"/>
+                <a:ea typeface="Helvetica Neue"/>
+                <a:cs typeface="Helvetica Neue"/>
+              </a:defRPr>
+            </a:pPr>
+            <a:r>
+              <a:rPr sz="1725" b="0">
+                <a:solidFill>
+                  <a:srgbClr val="B5EF6B"/>
+                </a:solidFill>
+                <a:latin typeface="Helvetica Neue"/>
+                <a:ea typeface="Helvetica Neue"/>
+                <a:cs typeface="Helvetica Neue"/>
+              </a:rPr>
+              <a:t>dorahacks.io/buidl/49254</a:t>
+            </a:r>
+          </a:p>
+        </p:txBody>
+      </p:sp>
+      <p:sp>
+        <p:nvSpPr>
+          <p:cNvPr id="6" name="">
+            <a:extLst xmlns:a="http://schemas.openxmlformats.org/drawingml/2006/main">
+              <a:ext uri="{FF2B5EF4-FFF2-40B4-BE49-F238E27FC236}">
+                <a16:creationId xmlns:a16="http://schemas.microsoft.com/office/drawing/2014/main" id="{B437B6E1-9A9C-4581-86B4-6B7B2D58863E}"/>
               </a:ext>
             </a:extLst>
           </p:cNvPr>
@@ -5536,10 +5593,10 @@
       </p:sp>
       <p:sp>
         <p:nvSpPr>
-          <p:cNvPr id="6" name="">
-            <a:extLst xmlns:a="http://schemas.openxmlformats.org/drawingml/2006/main">
-              <a:ext uri="{FF2B5EF4-FFF2-40B4-BE49-F238E27FC236}">
-                <a16:creationId xmlns:a16="http://schemas.microsoft.com/office/drawing/2014/main" id="{36C2EB1B-67DD-4839-BEC4-07660ED3857E}"/>
+          <p:cNvPr id="7" name="">
+            <a:extLst xmlns:a="http://schemas.openxmlformats.org/drawingml/2006/main">
+              <a:ext uri="{FF2B5EF4-FFF2-40B4-BE49-F238E27FC236}">
+                <a16:creationId xmlns:a16="http://schemas.microsoft.com/office/drawing/2014/main" id="{84250B97-69CF-4A41-BCCE-362E9C276A09}"/>
               </a:ext>
             </a:extLst>
           </p:cNvPr>
@@ -5593,10 +5650,67 @@
       </p:sp>
       <p:sp>
         <p:nvSpPr>
-          <p:cNvPr id="7" name="">
-            <a:extLst xmlns:a="http://schemas.openxmlformats.org/drawingml/2006/main">
-              <a:ext uri="{FF2B5EF4-FFF2-40B4-BE49-F238E27FC236}">
-                <a16:creationId xmlns:a16="http://schemas.microsoft.com/office/drawing/2014/main" id="{30174778-C18F-4F8A-8F79-342BF1B486B1}"/>
+          <p:cNvPr id="8" name="">
+            <a:extLst xmlns:a="http://schemas.openxmlformats.org/drawingml/2006/main">
+              <a:ext uri="{FF2B5EF4-FFF2-40B4-BE49-F238E27FC236}">
+                <a16:creationId xmlns:a16="http://schemas.microsoft.com/office/drawing/2014/main" id="{9D908753-DA50-4484-A1DF-E708DC14E667}"/>
+              </a:ext>
+            </a:extLst>
+          </p:cNvPr>
+          <p:cNvSpPr>
+            <a:spLocks xmlns:a="http://schemas.openxmlformats.org/drawingml/2006/main" noGrp="1"/>
+          </p:cNvSpPr>
+          <p:nvPr/>
+        </p:nvSpPr>
+        <p:spPr>
+          <a:xfrm xmlns:a="http://schemas.openxmlformats.org/drawingml/2006/main">
+            <a:off x="685800" y="4819650"/>
+            <a:ext cx="10820400" cy="285750"/>
+          </a:xfrm>
+          <a:prstGeom xmlns:a="http://schemas.openxmlformats.org/drawingml/2006/main" prst="rect">
+            <a:avLst/>
+          </a:prstGeom>
+          <a:noFill xmlns:a="http://schemas.openxmlformats.org/drawingml/2006/main"/>
+          <a:ln xmlns:a="http://schemas.openxmlformats.org/drawingml/2006/main" w="0">
+            <a:noFill/>
+          </a:ln>
+        </p:spPr>
+        <p:txBody>
+          <a:bodyPr xmlns:a="http://schemas.openxmlformats.org/drawingml/2006/main">
+            <a:noAutofit/>
+          </a:bodyPr>
+          <a:lstStyle xmlns:a="http://schemas.openxmlformats.org/drawingml/2006/main"/>
+          <a:p xmlns:a="http://schemas.openxmlformats.org/drawingml/2006/main">
+            <a:pPr>
+              <a:defRPr sz="1575" b="0">
+                <a:solidFill>
+                  <a:srgbClr val="B5EF6B"/>
+                </a:solidFill>
+                <a:latin typeface="Helvetica Neue"/>
+                <a:ea typeface="Helvetica Neue"/>
+                <a:cs typeface="Helvetica Neue"/>
+              </a:defRPr>
+            </a:pPr>
+            <a:r>
+              <a:rPr sz="1575" b="0">
+                <a:solidFill>
+                  <a:srgbClr val="B5EF6B"/>
+                </a:solidFill>
+                <a:latin typeface="Helvetica Neue"/>
+                <a:ea typeface="Helvetica Neue"/>
+                <a:cs typeface="Helvetica Neue"/>
+              </a:rPr>
+              <a:t>youtu.be/CYLWG-bSSB8</a:t>
+            </a:r>
+          </a:p>
+        </p:txBody>
+      </p:sp>
+      <p:sp>
+        <p:nvSpPr>
+          <p:cNvPr id="9" name="">
+            <a:extLst xmlns:a="http://schemas.openxmlformats.org/drawingml/2006/main">
+              <a:ext uri="{FF2B5EF4-FFF2-40B4-BE49-F238E27FC236}">
+                <a16:creationId xmlns:a16="http://schemas.microsoft.com/office/drawing/2014/main" id="{5ADDDD54-8D7B-456F-9524-8E28D94B0868}"/>
               </a:ext>
             </a:extLst>
           </p:cNvPr>
@@ -5643,17 +5757,17 @@
                 <a:ea typeface="Helvetica Neue"/>
                 <a:cs typeface="Helvetica Neue"/>
               </a:rPr>
-              <a:t>Final submission steps</a:t>
-            </a:r>
-          </a:p>
-        </p:txBody>
-      </p:sp>
-      <p:sp>
-        <p:nvSpPr>
-          <p:cNvPr id="8" name="">
-            <a:extLst xmlns:a="http://schemas.openxmlformats.org/drawingml/2006/main">
-              <a:ext uri="{FF2B5EF4-FFF2-40B4-BE49-F238E27FC236}">
-                <a16:creationId xmlns:a16="http://schemas.microsoft.com/office/drawing/2014/main" id="{2AA0918D-9ADB-427A-8B10-50E4B166A209}"/>
+              <a:t>Submitted, under review</a:t>
+            </a:r>
+          </a:p>
+        </p:txBody>
+      </p:sp>
+      <p:sp>
+        <p:nvSpPr>
+          <p:cNvPr id="10" name="">
+            <a:extLst xmlns:a="http://schemas.openxmlformats.org/drawingml/2006/main">
+              <a:ext uri="{FF2B5EF4-FFF2-40B4-BE49-F238E27FC236}">
+                <a16:creationId xmlns:a16="http://schemas.microsoft.com/office/drawing/2014/main" id="{A4B15E43-A12C-4770-BF64-1ECE0ADF299D}"/>
               </a:ext>
             </a:extLst>
           </p:cNvPr>
@@ -5700,7 +5814,7 @@
                 <a:ea typeface="Helvetica Neue"/>
                 <a:cs typeface="Helvetica Neue"/>
               </a:rPr>
-              <a:t>Hosted video ready. Final DoraHacks agreement and X post remain.</a:t>
+              <a:t>YouTube public. X post published. DoraHacks visibility awaits moderation.</a:t>
             </a:r>
           </a:p>
         </p:txBody>
@@ -5708,7 +5822,7 @@
     </p:spTree>
     <p:extLst>
       <p:ext uri="{BB962C8B-B14F-4D97-AF65-F5344CB8AC3E}">
-        <p14:creationId xmlns:p14="http://schemas.microsoft.com/office/powerpoint/2010/main" val="491928365"/>
+        <p14:creationId xmlns:p14="http://schemas.microsoft.com/office/powerpoint/2010/main" val="154320941"/>
       </p:ext>
     </p:extLst>
   </p:cSld>

</xml_diff>